<commit_message>
UT Teaching Award 2026
</commit_message>
<xml_diff>
--- a/images/awards.pptx
+++ b/images/awards.pptx
@@ -228,7 +228,7 @@
           <a:p>
             <a:fld id="{B1913588-C2C1-4AB8-9F0D-04EC72C1EC15}" type="datetimeFigureOut">
               <a:rPr lang="en-US" smtClean="0"/>
-              <a:t>8/3/2026</a:t>
+              <a:t>10/15/2026</a:t>
             </a:fld>
             <a:endParaRPr lang="en-US"/>
           </a:p>
@@ -626,7 +626,7 @@
           <a:p>
             <a:fld id="{B8700A39-06E1-486D-9C71-A159ABBEACA4}" type="datetimeFigureOut">
               <a:rPr lang="en-US" smtClean="0"/>
-              <a:t>8/3/2026</a:t>
+              <a:t>10/15/2026</a:t>
             </a:fld>
             <a:endParaRPr lang="en-US"/>
           </a:p>
@@ -796,7 +796,7 @@
           <a:p>
             <a:fld id="{B8700A39-06E1-486D-9C71-A159ABBEACA4}" type="datetimeFigureOut">
               <a:rPr lang="en-US" smtClean="0"/>
-              <a:t>8/3/2026</a:t>
+              <a:t>10/15/2026</a:t>
             </a:fld>
             <a:endParaRPr lang="en-US"/>
           </a:p>
@@ -976,7 +976,7 @@
           <a:p>
             <a:fld id="{B8700A39-06E1-486D-9C71-A159ABBEACA4}" type="datetimeFigureOut">
               <a:rPr lang="en-US" smtClean="0"/>
-              <a:t>8/3/2026</a:t>
+              <a:t>10/15/2026</a:t>
             </a:fld>
             <a:endParaRPr lang="en-US"/>
           </a:p>
@@ -1146,7 +1146,7 @@
           <a:p>
             <a:fld id="{B8700A39-06E1-486D-9C71-A159ABBEACA4}" type="datetimeFigureOut">
               <a:rPr lang="en-US" smtClean="0"/>
-              <a:t>8/3/2026</a:t>
+              <a:t>10/15/2026</a:t>
             </a:fld>
             <a:endParaRPr lang="en-US"/>
           </a:p>
@@ -1392,7 +1392,7 @@
           <a:p>
             <a:fld id="{B8700A39-06E1-486D-9C71-A159ABBEACA4}" type="datetimeFigureOut">
               <a:rPr lang="en-US" smtClean="0"/>
-              <a:t>8/3/2026</a:t>
+              <a:t>10/15/2026</a:t>
             </a:fld>
             <a:endParaRPr lang="en-US"/>
           </a:p>
@@ -1624,7 +1624,7 @@
           <a:p>
             <a:fld id="{B8700A39-06E1-486D-9C71-A159ABBEACA4}" type="datetimeFigureOut">
               <a:rPr lang="en-US" smtClean="0"/>
-              <a:t>8/3/2026</a:t>
+              <a:t>10/15/2026</a:t>
             </a:fld>
             <a:endParaRPr lang="en-US"/>
           </a:p>
@@ -1991,7 +1991,7 @@
           <a:p>
             <a:fld id="{B8700A39-06E1-486D-9C71-A159ABBEACA4}" type="datetimeFigureOut">
               <a:rPr lang="en-US" smtClean="0"/>
-              <a:t>8/3/2026</a:t>
+              <a:t>10/15/2026</a:t>
             </a:fld>
             <a:endParaRPr lang="en-US"/>
           </a:p>
@@ -2109,7 +2109,7 @@
           <a:p>
             <a:fld id="{B8700A39-06E1-486D-9C71-A159ABBEACA4}" type="datetimeFigureOut">
               <a:rPr lang="en-US" smtClean="0"/>
-              <a:t>8/3/2026</a:t>
+              <a:t>10/15/2026</a:t>
             </a:fld>
             <a:endParaRPr lang="en-US"/>
           </a:p>
@@ -2204,7 +2204,7 @@
           <a:p>
             <a:fld id="{B8700A39-06E1-486D-9C71-A159ABBEACA4}" type="datetimeFigureOut">
               <a:rPr lang="en-US" smtClean="0"/>
-              <a:t>8/3/2026</a:t>
+              <a:t>10/15/2026</a:t>
             </a:fld>
             <a:endParaRPr lang="en-US"/>
           </a:p>
@@ -2481,7 +2481,7 @@
           <a:p>
             <a:fld id="{B8700A39-06E1-486D-9C71-A159ABBEACA4}" type="datetimeFigureOut">
               <a:rPr lang="en-US" smtClean="0"/>
-              <a:t>8/3/2026</a:t>
+              <a:t>10/15/2026</a:t>
             </a:fld>
             <a:endParaRPr lang="en-US"/>
           </a:p>
@@ -2738,7 +2738,7 @@
           <a:p>
             <a:fld id="{B8700A39-06E1-486D-9C71-A159ABBEACA4}" type="datetimeFigureOut">
               <a:rPr lang="en-US" smtClean="0"/>
-              <a:t>8/3/2026</a:t>
+              <a:t>10/15/2026</a:t>
             </a:fld>
             <a:endParaRPr lang="en-US"/>
           </a:p>
@@ -2951,7 +2951,7 @@
           <a:p>
             <a:fld id="{B8700A39-06E1-486D-9C71-A159ABBEACA4}" type="datetimeFigureOut">
               <a:rPr lang="en-US" smtClean="0"/>
-              <a:t>8/3/2026</a:t>
+              <a:t>10/15/2026</a:t>
             </a:fld>
             <a:endParaRPr lang="en-US"/>
           </a:p>
@@ -3649,6 +3649,16 @@
           <a:lstStyle/>
           <a:p>
             <a:pPr algn="ctr"/>
+            <a:r>
+              <a:rPr lang="en-US" sz="800" b="1">
+                <a:solidFill>
+                  <a:srgbClr val="042433"/>
+                </a:solidFill>
+                <a:latin typeface="Arial" panose="020B0604020202020204" pitchFamily="34" charset="0"/>
+                <a:cs typeface="Arial" panose="020B0604020202020204" pitchFamily="34" charset="0"/>
+              </a:rPr>
+              <a:t>Best</a:t>
+            </a:r>
             <a:br>
               <a:rPr lang="en-US" sz="800" b="1" dirty="0">
                 <a:solidFill>

</xml_diff>